<commit_message>
Complete hosted case study workflow
Co-authored-by: Copilot App <223556219+Copilot@users.noreply.github.com>

Copilot-Session: 1c91c665-be76-4554-8bb3-b5021e69c436
</commit_message>
<xml_diff>
--- a/evaluation/corpus/v1/sources/fabrikam-architecture.pptx
+++ b/evaluation/corpus/v1/sources/fabrikam-architecture.pptx
@@ -3313,7 +3313,7 @@
                 </a:solidFill>
                 <a:latin typeface="Arial"/>
               </a:rPr>
-              <a:t>Work IQ</a:t>
+              <a:t>Direct upload</a:t>
             </a:r>
           </a:p>
           <a:p>
@@ -3329,7 +3329,7 @@
                 </a:solidFill>
                 <a:latin typeface="Arial"/>
               </a:rPr>
-              <a:t>Grounded user context</a:t>
+              <a:t>Validated evidence transfer</a:t>
             </a:r>
           </a:p>
         </p:txBody>
@@ -3381,7 +3381,7 @@
                 </a:solidFill>
                 <a:latin typeface="Arial"/>
               </a:rPr>
-              <a:t>Microsoft Graph</a:t>
+              <a:t>Foundry OBO</a:t>
             </a:r>
           </a:p>
           <a:p>
@@ -3397,7 +3397,7 @@
                 </a:solidFill>
                 <a:latin typeface="Arial"/>
               </a:rPr>
-              <a:t>Delegated file retrieval</a:t>
+              <a:t>User-authorized orchestration</a:t>
             </a:r>
           </a:p>
         </p:txBody>

</xml_diff>